<commit_message>
slides: fix title slide to full name 'S4D: Self-Taught Semi-Self Speculative Decoding'
</commit_message>
<xml_diff>
--- a/chain/nicole/slides.pptx
+++ b/chain/nicole/slides.pptx
@@ -23,7 +23,7 @@
     <p:sldId id="271" r:id="rId23"/>
     <p:sldId id="272" r:id="rId24"/>
   </p:sldIdLst>
-  <p:sldSz cx="12191997" cy="6858000" type="screen4x3"/>
+  <p:sldSz cx="12191821" cy="6858000" type="screen4x3"/>
   <p:notesSz cx="6858000" cy="9144000"/>
   <p:defaultTextStyle>
     <a:defPPr>
@@ -4661,7 +4661,7 @@
         <p:spPr>
           <a:xfrm>
             <a:off x="0" y="0"/>
-            <a:ext cx="12191997" cy="6858000"/>
+            <a:ext cx="12191821" cy="6858000"/>
           </a:xfrm>
           <a:prstGeom prst="rect">
             <a:avLst/>
@@ -4703,7 +4703,7 @@
         <p:spPr>
           <a:xfrm>
             <a:off x="0" y="0"/>
-            <a:ext cx="12191997" cy="6858000"/>
+            <a:ext cx="12191821" cy="6858000"/>
           </a:xfrm>
           <a:prstGeom prst="rect">
             <a:avLst/>
@@ -4745,7 +4745,7 @@
         <p:spPr>
           <a:xfrm>
             <a:off x="0" y="0"/>
-            <a:ext cx="12191997" cy="6858000"/>
+            <a:ext cx="12191821" cy="6858000"/>
           </a:xfrm>
           <a:prstGeom prst="rect">
             <a:avLst/>
@@ -4787,7 +4787,7 @@
         <p:spPr>
           <a:xfrm>
             <a:off x="0" y="0"/>
-            <a:ext cx="12191997" cy="6858000"/>
+            <a:ext cx="12191821" cy="6858000"/>
           </a:xfrm>
           <a:prstGeom prst="rect">
             <a:avLst/>
@@ -4829,7 +4829,7 @@
         <p:spPr>
           <a:xfrm>
             <a:off x="0" y="0"/>
-            <a:ext cx="12191997" cy="6858000"/>
+            <a:ext cx="12191821" cy="6858000"/>
           </a:xfrm>
           <a:prstGeom prst="rect">
             <a:avLst/>
@@ -4871,7 +4871,7 @@
         <p:spPr>
           <a:xfrm>
             <a:off x="0" y="0"/>
-            <a:ext cx="12191997" cy="6858000"/>
+            <a:ext cx="12191821" cy="6858000"/>
           </a:xfrm>
           <a:prstGeom prst="rect">
             <a:avLst/>
@@ -4913,7 +4913,7 @@
         <p:spPr>
           <a:xfrm>
             <a:off x="0" y="0"/>
-            <a:ext cx="12191997" cy="6858000"/>
+            <a:ext cx="12191821" cy="6858000"/>
           </a:xfrm>
           <a:prstGeom prst="rect">
             <a:avLst/>
@@ -4955,7 +4955,7 @@
         <p:spPr>
           <a:xfrm>
             <a:off x="0" y="0"/>
-            <a:ext cx="12191997" cy="6858000"/>
+            <a:ext cx="12191821" cy="6858000"/>
           </a:xfrm>
           <a:prstGeom prst="rect">
             <a:avLst/>
@@ -4997,7 +4997,7 @@
         <p:spPr>
           <a:xfrm>
             <a:off x="0" y="0"/>
-            <a:ext cx="12191997" cy="6858000"/>
+            <a:ext cx="12191821" cy="6858000"/>
           </a:xfrm>
           <a:prstGeom prst="rect">
             <a:avLst/>
@@ -5039,7 +5039,7 @@
         <p:spPr>
           <a:xfrm>
             <a:off x="0" y="0"/>
-            <a:ext cx="12191997" cy="6858000"/>
+            <a:ext cx="12191821" cy="6858000"/>
           </a:xfrm>
           <a:prstGeom prst="rect">
             <a:avLst/>
@@ -5081,7 +5081,7 @@
         <p:spPr>
           <a:xfrm>
             <a:off x="0" y="0"/>
-            <a:ext cx="12191997" cy="6858000"/>
+            <a:ext cx="12191821" cy="6858000"/>
           </a:xfrm>
           <a:prstGeom prst="rect">
             <a:avLst/>
@@ -5123,7 +5123,7 @@
         <p:spPr>
           <a:xfrm>
             <a:off x="0" y="0"/>
-            <a:ext cx="12191997" cy="6858000"/>
+            <a:ext cx="12191821" cy="6858000"/>
           </a:xfrm>
           <a:prstGeom prst="rect">
             <a:avLst/>
@@ -5165,7 +5165,7 @@
         <p:spPr>
           <a:xfrm>
             <a:off x="0" y="0"/>
-            <a:ext cx="12191997" cy="6858000"/>
+            <a:ext cx="12191821" cy="6858000"/>
           </a:xfrm>
           <a:prstGeom prst="rect">
             <a:avLst/>
@@ -5207,7 +5207,7 @@
         <p:spPr>
           <a:xfrm>
             <a:off x="0" y="0"/>
-            <a:ext cx="12191997" cy="6858000"/>
+            <a:ext cx="12191821" cy="6858000"/>
           </a:xfrm>
           <a:prstGeom prst="rect">
             <a:avLst/>
@@ -5249,7 +5249,7 @@
         <p:spPr>
           <a:xfrm>
             <a:off x="0" y="0"/>
-            <a:ext cx="12191997" cy="6858000"/>
+            <a:ext cx="12191821" cy="6858000"/>
           </a:xfrm>
           <a:prstGeom prst="rect">
             <a:avLst/>
@@ -5291,7 +5291,7 @@
         <p:spPr>
           <a:xfrm>
             <a:off x="0" y="0"/>
-            <a:ext cx="12191997" cy="6858000"/>
+            <a:ext cx="12191821" cy="6858000"/>
           </a:xfrm>
           <a:prstGeom prst="rect">
             <a:avLst/>
@@ -5333,7 +5333,7 @@
         <p:spPr>
           <a:xfrm>
             <a:off x="0" y="0"/>
-            <a:ext cx="12191997" cy="6858000"/>
+            <a:ext cx="12191821" cy="6858000"/>
           </a:xfrm>
           <a:prstGeom prst="rect">
             <a:avLst/>

</xml_diff>

<commit_message>
full deck: add Fully Self-Speculative Decoding (S5D) bonus slide with Pareto
</commit_message>
<xml_diff>
--- a/chain/nicole/slides.pptx
+++ b/chain/nicole/slides.pptx
@@ -21,6 +21,7 @@
     <p:sldId id="269" r:id="rId21"/>
     <p:sldId id="270" r:id="rId22"/>
     <p:sldId id="271" r:id="rId23"/>
+    <p:sldId id="273" r:id="rId25"/>
     <p:sldId id="272" r:id="rId24"/>
   </p:sldIdLst>
   <p:sldSz cx="12191821" cy="6858000" type="screen4x3"/>
@@ -1079,6 +1080,76 @@
           <a:p>
             <a:r>
               <a:t>Three directions we're excited about. First, spec-spec decoding: the drafter itself is slow, so make it speculative too, a recursive hierarchy of drafters, and the gate now routes across levels, not just three tiers. Second, what we call KnapSpec: you have a fixed budget of expensive calls per sequence, so spend it like a knapsack, putting your verification budget on the tokens that most change the final answer. That directly attacks the proxy gap I showed earlier. Third, a correctness-floor objective: minimize cost subject to staying above an accuracy floor, which avoids the failure mode where naively optimizing for correctness collapses the policy. And then scale it up: bigger drafters, more tasks, and real wall-clock on a production inference engine.</a:t>
+            </a:r>
+          </a:p>
+        </p:txBody>
+      </p:sp>
+      <p:sp>
+        <p:nvSpPr>
+          <p:cNvPr id="4" name="Slide Number Placeholder 3"/>
+          <p:cNvSpPr>
+            <a:spLocks noGrp="1"/>
+          </p:cNvSpPr>
+          <p:nvPr>
+            <p:ph type="sldNum" idx="5" sz="quarter"/>
+          </p:nvPr>
+        </p:nvSpPr>
+        <p:spPr/>
+      </p:sp>
+    </p:spTree>
+  </p:cSld>
+  <p:clrMapOvr>
+    <a:masterClrMapping/>
+  </p:clrMapOvr>
+</p:notes>
+</file>
+
+<file path=ppt/notesSlides/notesSlide18.xml><?xml version="1.0" encoding="utf-8"?>
+<p:notes xmlns:a="http://schemas.openxmlformats.org/drawingml/2006/main" xmlns:p="http://schemas.openxmlformats.org/presentationml/2006/main" xmlns:r="http://schemas.openxmlformats.org/officeDocument/2006/relationships">
+  <p:cSld>
+    <p:spTree>
+      <p:nvGrpSpPr>
+        <p:cNvPr id="1" name=""/>
+        <p:cNvGrpSpPr/>
+        <p:nvPr/>
+      </p:nvGrpSpPr>
+      <p:grpSpPr>
+        <a:xfrm>
+          <a:off x="0" y="0"/>
+          <a:ext cx="0" cy="0"/>
+          <a:chOff x="0" y="0"/>
+          <a:chExt cx="0" cy="0"/>
+        </a:xfrm>
+      </p:grpSpPr>
+      <p:sp>
+        <p:nvSpPr>
+          <p:cNvPr id="2" name="Slide Image Placeholder 1"/>
+          <p:cNvSpPr>
+            <a:spLocks noGrp="1"/>
+          </p:cNvSpPr>
+          <p:nvPr>
+            <p:ph type="sldImg" idx="2"/>
+          </p:nvPr>
+        </p:nvSpPr>
+        <p:spPr/>
+      </p:sp>
+      <p:sp>
+        <p:nvSpPr>
+          <p:cNvPr id="3" name="Notes Placeholder 2"/>
+          <p:cNvSpPr>
+            <a:spLocks noGrp="1"/>
+          </p:cNvSpPr>
+          <p:nvPr>
+            <p:ph type="body" idx="3" sz="quarter"/>
+          </p:nvPr>
+        </p:nvSpPr>
+        <p:spPr/>
+        <p:txBody>
+          <a:bodyPr/>
+          <a:lstStyle/>
+          <a:p>
+            <a:r>
+              <a:t>A cool extension from the last two hours. S-four-D is Semi-Self: the slim verifier checks its own draft, but the drafter is a separate model. We close the loop. In Full-Self, the drafter is also a layer-subset of the same verifier. One 14B model plays all three roles: draft, slim verifier, and full verifier, at three layer-skip levels. KnapSpec autotunes the skips; our learned gate routes. It trains end-to-end and converges to 0.95 token match. The payoff is single-model deployment, no separate drafter to host or align.</a:t>
             </a:r>
           </a:p>
         </p:txBody>
@@ -5004,6 +5075,263 @@
           </a:prstGeom>
         </p:spPr>
       </p:pic>
+    </p:spTree>
+  </p:cSld>
+  <p:clrMapOvr>
+    <a:masterClrMapping/>
+  </p:clrMapOvr>
+</p:sld>
+</file>
+
+<file path=ppt/slides/slide18.xml><?xml version="1.0" encoding="utf-8"?>
+<p:sld xmlns:a="http://schemas.openxmlformats.org/drawingml/2006/main" xmlns:p="http://schemas.openxmlformats.org/presentationml/2006/main" xmlns:r="http://schemas.openxmlformats.org/officeDocument/2006/relationships">
+  <p:cSld>
+    <p:spTree>
+      <p:nvGrpSpPr>
+        <p:cNvPr id="1" name=""/>
+        <p:cNvGrpSpPr/>
+        <p:nvPr/>
+      </p:nvGrpSpPr>
+      <p:grpSpPr/>
+      <p:sp>
+        <p:nvSpPr>
+          <p:cNvPr id="2" name="Rectangle 1"/>
+          <p:cNvSpPr/>
+          <p:nvPr/>
+        </p:nvSpPr>
+        <p:spPr>
+          <a:xfrm>
+            <a:off x="0" y="0"/>
+            <a:ext cx="12191821" cy="960120"/>
+          </a:xfrm>
+          <a:prstGeom prst="rect">
+            <a:avLst/>
+          </a:prstGeom>
+          <a:solidFill>
+            <a:srgbClr val="2E3A8C"/>
+          </a:solidFill>
+          <a:ln>
+            <a:noFill/>
+          </a:ln>
+        </p:spPr>
+        <p:style>
+          <a:lnRef idx="1">
+            <a:schemeClr val="accent1"/>
+          </a:lnRef>
+          <a:fillRef idx="3">
+            <a:schemeClr val="accent1"/>
+          </a:fillRef>
+          <a:effectRef idx="2">
+            <a:schemeClr val="accent1"/>
+          </a:effectRef>
+          <a:fontRef idx="minor">
+            <a:schemeClr val="lt1"/>
+          </a:fontRef>
+        </p:style>
+        <p:txBody>
+          <a:bodyPr rtlCol="0" anchor="ctr"/>
+          <a:lstStyle/>
+          <a:p>
+            <a:pPr algn="ctr">
+              <a:defRPr b="1" sz="2600">
+                <a:solidFill>
+                  <a:srgbClr val="FFFFFF"/>
+                </a:solidFill>
+              </a:defRPr>
+            </a:pPr>
+            <a:r>
+              <a:t>Bonus: Fully Self-Speculative Decoding (S⁵D)</a:t>
+            </a:r>
+          </a:p>
+        </p:txBody>
+      </p:sp>
+      <p:sp>
+        <p:nvSpPr>
+          <p:cNvPr id="3" name="TextBox 2"/>
+          <p:cNvSpPr txBox="1"/>
+          <p:nvPr/>
+        </p:nvSpPr>
+        <p:spPr>
+          <a:xfrm>
+            <a:off x="487672" y="1234440"/>
+            <a:ext cx="5608237" cy="5074920"/>
+          </a:xfrm>
+          <a:prstGeom prst="rect">
+            <a:avLst/>
+          </a:prstGeom>
+          <a:noFill/>
+        </p:spPr>
+        <p:txBody>
+          <a:bodyPr wrap="square">
+            <a:spAutoFit/>
+          </a:bodyPr>
+          <a:lstStyle/>
+          <a:p>
+            <a:pPr>
+              <a:spcAft>
+                <a:spcPts val="700"/>
+              </a:spcAft>
+              <a:defRPr sz="1500">
+                <a:solidFill>
+                  <a:srgbClr val="000000"/>
+                </a:solidFill>
+              </a:defRPr>
+            </a:pPr>
+            <a:r>
+              <a:t>• S⁴D is Semi-Self: q′ verifies its own draft, but the drafter is a separate model.</a:t>
+            </a:r>
+          </a:p>
+          <a:p>
+            <a:pPr>
+              <a:spcAft>
+                <a:spcPts val="700"/>
+              </a:spcAft>
+              <a:defRPr sz="1500">
+                <a:solidFill>
+                  <a:srgbClr val="000000"/>
+                </a:solidFill>
+              </a:defRPr>
+            </a:pPr>
+            <a:r>
+              <a:t>• We close the loop — Full-Self: the drafter is also a layer-subset of the verifier.</a:t>
+            </a:r>
+          </a:p>
+          <a:p>
+            <a:pPr>
+              <a:spcAft>
+                <a:spcPts val="700"/>
+              </a:spcAft>
+              <a:defRPr sz="1500">
+                <a:solidFill>
+                  <a:srgbClr val="000000"/>
+                </a:solidFill>
+              </a:defRPr>
+            </a:pPr>
+            <a:r>
+              <a:t>• One 14B model, three roles:</a:t>
+            </a:r>
+          </a:p>
+          <a:p>
+            <a:pPr>
+              <a:spcAft>
+                <a:spcPts val="700"/>
+              </a:spcAft>
+              <a:defRPr sz="1300">
+                <a:solidFill>
+                  <a:srgbClr val="555555"/>
+                </a:solidFill>
+              </a:defRPr>
+            </a:pPr>
+            <a:r>
+              <a:t>      – draft (keep ~8–20 layers) → q′ (~26) → full q</a:t>
+            </a:r>
+          </a:p>
+          <a:p>
+            <a:pPr>
+              <a:spcAft>
+                <a:spcPts val="700"/>
+              </a:spcAft>
+              <a:defRPr sz="1500">
+                <a:solidFill>
+                  <a:srgbClr val="000000"/>
+                </a:solidFill>
+              </a:defRPr>
+            </a:pPr>
+            <a:r>
+              <a:t>• KnapSpec autotunes all three skip levels; the learned RL gate routes.</a:t>
+            </a:r>
+          </a:p>
+          <a:p>
+            <a:pPr>
+              <a:spcAft>
+                <a:spcPts val="700"/>
+              </a:spcAft>
+              <a:defRPr sz="1500">
+                <a:solidFill>
+                  <a:srgbClr val="000000"/>
+                </a:solidFill>
+              </a:defRPr>
+            </a:pPr>
+            <a:r>
+              <a:t>• No separate drafter — single-model deployment.</a:t>
+            </a:r>
+          </a:p>
+          <a:p>
+            <a:pPr>
+              <a:spcAft>
+                <a:spcPts val="700"/>
+              </a:spcAft>
+              <a:defRPr sz="1500">
+                <a:solidFill>
+                  <a:srgbClr val="000000"/>
+                </a:solidFill>
+              </a:defRPr>
+            </a:pPr>
+            <a:r>
+              <a:t>• Trains end-to-end: token-match converges to 0.95 in ~40 RL steps.</a:t>
+            </a:r>
+          </a:p>
+        </p:txBody>
+      </p:sp>
+      <p:pic>
+        <p:nvPicPr>
+          <p:cNvPr id="4" name="Picture 3" descr="pareto_s5d.png"/>
+          <p:cNvPicPr>
+            <a:picLocks noChangeAspect="1"/>
+          </p:cNvPicPr>
+          <p:nvPr/>
+        </p:nvPicPr>
+        <p:blipFill>
+          <a:blip r:embed="rId2"/>
+          <a:stretch>
+            <a:fillRect/>
+          </a:stretch>
+        </p:blipFill>
+        <p:spPr>
+          <a:xfrm>
+            <a:off x="6217828" y="2057400"/>
+            <a:ext cx="5852074" cy="3562132"/>
+          </a:xfrm>
+          <a:prstGeom prst="rect">
+            <a:avLst/>
+          </a:prstGeom>
+        </p:spPr>
+      </p:pic>
+      <p:sp>
+        <p:nvSpPr>
+          <p:cNvPr id="5" name="TextBox 4"/>
+          <p:cNvSpPr txBox="1"/>
+          <p:nvPr/>
+        </p:nvSpPr>
+        <p:spPr>
+          <a:xfrm>
+            <a:off x="6217828" y="1303020"/>
+            <a:ext cx="5852074" cy="685800"/>
+          </a:xfrm>
+          <a:prstGeom prst="rect">
+            <a:avLst/>
+          </a:prstGeom>
+          <a:noFill/>
+        </p:spPr>
+        <p:txBody>
+          <a:bodyPr wrap="none">
+            <a:spAutoFit/>
+          </a:bodyPr>
+          <a:lstStyle/>
+          <a:p>
+            <a:pPr>
+              <a:defRPr sz="1100" i="1">
+                <a:solidFill>
+                  <a:srgbClr val="555555"/>
+                </a:solidFill>
+              </a:defRPr>
+            </a:pPr>
+            <a:r>
+              <a:t>Accuracy vs speedup: our measured points (★) + Full-Self (projected)</a:t>
+            </a:r>
+          </a:p>
+        </p:txBody>
+      </p:sp>
     </p:spTree>
   </p:cSld>
   <p:clrMapOvr>

</xml_diff>